<commit_message>
feat: update presentation files for Spring AI topics
</commit_message>
<xml_diff>
--- a/presentations/01-getting-started-with-spring-ai.pptx
+++ b/presentations/01-getting-started-with-spring-ai.pptx
@@ -3246,45 +3246,6 @@
           </a:p>
         </p:txBody>
       </p:sp>
-      <p:sp>
-        <p:nvSpPr>
-          <p:cNvPr id="18" name="Text 16"/>
-          <p:cNvSpPr/>
-          <p:nvPr/>
-        </p:nvSpPr>
-        <p:spPr>
-          <a:xfrm>
-            <a:off x="548640" y="5815584"/>
-            <a:ext cx="11064240" cy="448056"/>
-          </a:xfrm>
-          <a:prstGeom prst="rect">
-            <a:avLst/>
-          </a:prstGeom>
-          <a:noFill/>
-          <a:ln/>
-        </p:spPr>
-        <p:txBody>
-          <a:bodyPr wrap="square" lIns="0" tIns="0" rIns="0" bIns="0" rtlCol="0" anchor="t"/>
-          <a:lstStyle/>
-          <a:p>
-            <a:pPr marL="0" indent="0">
-              <a:buNone/>
-            </a:pPr>
-            <a:r>
-              <a:rPr lang="en-US" sz="1800" b="1" dirty="0">
-                <a:solidFill>
-                  <a:srgbClr val="397C25"/>
-                </a:solidFill>
-                <a:latin typeface="Calibri" pitchFamily="34" charset="0"/>
-                <a:ea typeface="Calibri" pitchFamily="34" charset="-122"/>
-                <a:cs typeface="Calibri" pitchFamily="34" charset="-120"/>
-              </a:rPr>
-              <a:t>Storage can change without moving history-management logic into the controller.</a:t>
-            </a:r>
-            <a:endParaRPr lang="en-US" sz="1800" dirty="0"/>
-          </a:p>
-        </p:txBody>
-      </p:sp>
     </p:spTree>
   </p:cSld>
   <p:clrMapOvr>
@@ -4032,45 +3993,6 @@
           </a:p>
         </p:txBody>
       </p:sp>
-      <p:sp>
-        <p:nvSpPr>
-          <p:cNvPr id="15" name="Text 13"/>
-          <p:cNvSpPr/>
-          <p:nvPr/>
-        </p:nvSpPr>
-        <p:spPr>
-          <a:xfrm>
-            <a:off x="548640" y="5815584"/>
-            <a:ext cx="11064240" cy="448056"/>
-          </a:xfrm>
-          <a:prstGeom prst="rect">
-            <a:avLst/>
-          </a:prstGeom>
-          <a:noFill/>
-          <a:ln/>
-        </p:spPr>
-        <p:txBody>
-          <a:bodyPr wrap="square" lIns="0" tIns="0" rIns="0" bIns="0" rtlCol="0" anchor="t"/>
-          <a:lstStyle/>
-          <a:p>
-            <a:pPr marL="0" indent="0">
-              <a:buNone/>
-            </a:pPr>
-            <a:r>
-              <a:rPr lang="en-US" sz="1800" b="1" dirty="0">
-                <a:solidFill>
-                  <a:srgbClr val="397C25"/>
-                </a:solidFill>
-                <a:latin typeface="Calibri" pitchFamily="34" charset="0"/>
-                <a:ea typeface="Calibri" pitchFamily="34" charset="-122"/>
-                <a:cs typeface="Calibri" pitchFamily="34" charset="-120"/>
-              </a:rPr>
-              <a:t>Ten messages is not ten conversation turns, and it is not ten tokens.</a:t>
-            </a:r>
-            <a:endParaRPr lang="en-US" sz="1800" dirty="0"/>
-          </a:p>
-        </p:txBody>
-      </p:sp>
     </p:spTree>
   </p:cSld>
   <p:clrMapOvr>
@@ -6262,45 +6184,6 @@
           </a:p>
         </p:txBody>
       </p:sp>
-      <p:sp>
-        <p:nvSpPr>
-          <p:cNvPr id="61" name="Text 58"/>
-          <p:cNvSpPr/>
-          <p:nvPr/>
-        </p:nvSpPr>
-        <p:spPr>
-          <a:xfrm>
-            <a:off x="548640" y="5815584"/>
-            <a:ext cx="11064240" cy="448056"/>
-          </a:xfrm>
-          <a:prstGeom prst="rect">
-            <a:avLst/>
-          </a:prstGeom>
-          <a:noFill/>
-          <a:ln/>
-        </p:spPr>
-        <p:txBody>
-          <a:bodyPr wrap="square" lIns="0" tIns="0" rIns="0" bIns="0" rtlCol="0" anchor="t"/>
-          <a:lstStyle/>
-          <a:p>
-            <a:pPr marL="0" indent="0">
-              <a:buNone/>
-            </a:pPr>
-            <a:r>
-              <a:rPr lang="en-US" sz="1800" b="1" dirty="0">
-                <a:solidFill>
-                  <a:srgbClr val="397C25"/>
-                </a:solidFill>
-                <a:latin typeface="Calibri" pitchFamily="34" charset="0"/>
-                <a:ea typeface="Calibri" pitchFamily="34" charset="-122"/>
-                <a:cs typeface="Calibri" pitchFamily="34" charset="-120"/>
-              </a:rPr>
-              <a:t>Ten messages remain after trimming. A user/assistant exchange normally adds two messages.</a:t>
-            </a:r>
-            <a:endParaRPr lang="en-US" sz="1800" dirty="0"/>
-          </a:p>
-        </p:txBody>
-      </p:sp>
     </p:spTree>
   </p:cSld>
   <p:clrMapOvr>
@@ -6939,45 +6822,6 @@
           </a:p>
         </p:txBody>
       </p:sp>
-      <p:sp>
-        <p:nvSpPr>
-          <p:cNvPr id="15" name="Text 13"/>
-          <p:cNvSpPr/>
-          <p:nvPr/>
-        </p:nvSpPr>
-        <p:spPr>
-          <a:xfrm>
-            <a:off x="548640" y="5815584"/>
-            <a:ext cx="11064240" cy="448056"/>
-          </a:xfrm>
-          <a:prstGeom prst="rect">
-            <a:avLst/>
-          </a:prstGeom>
-          <a:noFill/>
-          <a:ln/>
-        </p:spPr>
-        <p:txBody>
-          <a:bodyPr wrap="square" lIns="0" tIns="0" rIns="0" bIns="0" rtlCol="0" anchor="t"/>
-          <a:lstStyle/>
-          <a:p>
-            <a:pPr marL="0" indent="0">
-              <a:buNone/>
-            </a:pPr>
-            <a:r>
-              <a:rPr lang="en-US" sz="1800" b="1" dirty="0">
-                <a:solidFill>
-                  <a:srgbClr val="397C25"/>
-                </a:solidFill>
-                <a:latin typeface="Calibri" pitchFamily="34" charset="0"/>
-                <a:ea typeface="Calibri" pitchFamily="34" charset="-122"/>
-                <a:cs typeface="Calibri" pitchFamily="34" charset="-120"/>
-              </a:rPr>
-              <a:t>ConversationService stays focused on conversation behavior.</a:t>
-            </a:r>
-            <a:endParaRPr lang="en-US" sz="1800" dirty="0"/>
-          </a:p>
-        </p:txBody>
-      </p:sp>
     </p:spTree>
   </p:cSld>
   <p:clrMapOvr>
@@ -7636,45 +7480,6 @@
           </a:p>
         </p:txBody>
       </p:sp>
-      <p:sp>
-        <p:nvSpPr>
-          <p:cNvPr id="15" name="Text 13"/>
-          <p:cNvSpPr/>
-          <p:nvPr/>
-        </p:nvSpPr>
-        <p:spPr>
-          <a:xfrm>
-            <a:off x="548640" y="5815584"/>
-            <a:ext cx="11064240" cy="448056"/>
-          </a:xfrm>
-          <a:prstGeom prst="rect">
-            <a:avLst/>
-          </a:prstGeom>
-          <a:noFill/>
-          <a:ln/>
-        </p:spPr>
-        <p:txBody>
-          <a:bodyPr wrap="square" lIns="0" tIns="0" rIns="0" bIns="0" rtlCol="0" anchor="t"/>
-          <a:lstStyle/>
-          <a:p>
-            <a:pPr marL="0" indent="0">
-              <a:buNone/>
-            </a:pPr>
-            <a:r>
-              <a:rPr lang="en-US" sz="1800" b="1" dirty="0">
-                <a:solidFill>
-                  <a:srgbClr val="397C25"/>
-                </a:solidFill>
-                <a:latin typeface="Calibri" pitchFamily="34" charset="0"/>
-                <a:ea typeface="Calibri" pitchFamily="34" charset="-122"/>
-                <a:cs typeface="Calibri" pitchFamily="34" charset="-120"/>
-              </a:rPr>
-              <a:t>Pass ChatMemory.CONVERSATION_ID explicitly on each stateful request.</a:t>
-            </a:r>
-            <a:endParaRPr lang="en-US" sz="1800" dirty="0"/>
-          </a:p>
-        </p:txBody>
-      </p:sp>
     </p:spTree>
   </p:cSld>
   <p:clrMapOvr>
@@ -8311,45 +8116,6 @@
           </a:p>
         </p:txBody>
       </p:sp>
-      <p:sp>
-        <p:nvSpPr>
-          <p:cNvPr id="15" name="Text 13"/>
-          <p:cNvSpPr/>
-          <p:nvPr/>
-        </p:nvSpPr>
-        <p:spPr>
-          <a:xfrm>
-            <a:off x="548640" y="5815584"/>
-            <a:ext cx="11064240" cy="448056"/>
-          </a:xfrm>
-          <a:prstGeom prst="rect">
-            <a:avLst/>
-          </a:prstGeom>
-          <a:noFill/>
-          <a:ln/>
-        </p:spPr>
-        <p:txBody>
-          <a:bodyPr wrap="square" lIns="0" tIns="0" rIns="0" bIns="0" rtlCol="0" anchor="t"/>
-          <a:lstStyle/>
-          <a:p>
-            <a:pPr marL="0" indent="0">
-              <a:buNone/>
-            </a:pPr>
-            <a:r>
-              <a:rPr lang="en-US" sz="1800" b="1" dirty="0">
-                <a:solidFill>
-                  <a:srgbClr val="397C25"/>
-                </a:solidFill>
-                <a:latin typeface="Calibri" pitchFamily="34" charset="0"/>
-                <a:ea typeface="Calibri" pitchFamily="34" charset="-122"/>
-                <a:cs typeface="Calibri" pitchFamily="34" charset="-120"/>
-              </a:rPr>
-              <a:t>ConversationService exposes lifecycle operations; in-memory state ends on restart.</a:t>
-            </a:r>
-            <a:endParaRPr lang="en-US" sz="1800" dirty="0"/>
-          </a:p>
-        </p:txBody>
-      </p:sp>
     </p:spTree>
   </p:cSld>
   <p:clrMapOvr>
@@ -8992,45 +8758,6 @@
           </a:p>
         </p:txBody>
       </p:sp>
-      <p:sp>
-        <p:nvSpPr>
-          <p:cNvPr id="18" name="Text 16"/>
-          <p:cNvSpPr/>
-          <p:nvPr/>
-        </p:nvSpPr>
-        <p:spPr>
-          <a:xfrm>
-            <a:off x="548640" y="5815584"/>
-            <a:ext cx="11064240" cy="448056"/>
-          </a:xfrm>
-          <a:prstGeom prst="rect">
-            <a:avLst/>
-          </a:prstGeom>
-          <a:noFill/>
-          <a:ln/>
-        </p:spPr>
-        <p:txBody>
-          <a:bodyPr wrap="square" lIns="0" tIns="0" rIns="0" bIns="0" rtlCol="0" anchor="t"/>
-          <a:lstStyle/>
-          <a:p>
-            <a:pPr marL="0" indent="0">
-              <a:buNone/>
-            </a:pPr>
-            <a:r>
-              <a:rPr lang="en-US" sz="1800" b="1" dirty="0">
-                <a:solidFill>
-                  <a:srgbClr val="397C25"/>
-                </a:solidFill>
-                <a:latin typeface="Calibri" pitchFamily="34" charset="0"/>
-                <a:ea typeface="Calibri" pitchFamily="34" charset="-122"/>
-                <a:cs typeface="Calibri" pitchFamily="34" charset="-120"/>
-              </a:rPr>
-              <a:t>Follow the Module 01 deployment guide; model availability and regional quota can vary.</a:t>
-            </a:r>
-            <a:endParaRPr lang="en-US" sz="1800" dirty="0"/>
-          </a:p>
-        </p:txBody>
-      </p:sp>
     </p:spTree>
   </p:cSld>
   <p:clrMapOvr>
@@ -9673,45 +9400,6 @@
           </a:p>
         </p:txBody>
       </p:sp>
-      <p:sp>
-        <p:nvSpPr>
-          <p:cNvPr id="18" name="Text 16"/>
-          <p:cNvSpPr/>
-          <p:nvPr/>
-        </p:nvSpPr>
-        <p:spPr>
-          <a:xfrm>
-            <a:off x="548640" y="5815584"/>
-            <a:ext cx="11064240" cy="448056"/>
-          </a:xfrm>
-          <a:prstGeom prst="rect">
-            <a:avLst/>
-          </a:prstGeom>
-          <a:noFill/>
-          <a:ln/>
-        </p:spPr>
-        <p:txBody>
-          <a:bodyPr wrap="square" lIns="0" tIns="0" rIns="0" bIns="0" rtlCol="0" anchor="t"/>
-          <a:lstStyle/>
-          <a:p>
-            <a:pPr marL="0" indent="0">
-              <a:buNone/>
-            </a:pPr>
-            <a:r>
-              <a:rPr lang="en-US" sz="1800" b="1" dirty="0">
-                <a:solidFill>
-                  <a:srgbClr val="397C25"/>
-                </a:solidFill>
-                <a:latin typeface="Calibri" pitchFamily="34" charset="0"/>
-                <a:ea typeface="Calibri" pitchFamily="34" charset="-122"/>
-                <a:cs typeface="Calibri" pitchFamily="34" charset="-120"/>
-              </a:rPr>
-              <a:t>The start script loads the root environment file and builds a missing JAR.</a:t>
-            </a:r>
-            <a:endParaRPr lang="en-US" sz="1800" dirty="0"/>
-          </a:p>
-        </p:txBody>
-      </p:sp>
     </p:spTree>
   </p:cSld>
   <p:clrMapOvr>
@@ -10159,45 +9847,6 @@
           </a:p>
         </p:txBody>
       </p:sp>
-      <p:sp>
-        <p:nvSpPr>
-          <p:cNvPr id="13" name="Text 10"/>
-          <p:cNvSpPr/>
-          <p:nvPr/>
-        </p:nvSpPr>
-        <p:spPr>
-          <a:xfrm>
-            <a:off x="548640" y="5815584"/>
-            <a:ext cx="11064240" cy="448056"/>
-          </a:xfrm>
-          <a:prstGeom prst="rect">
-            <a:avLst/>
-          </a:prstGeom>
-          <a:noFill/>
-          <a:ln/>
-        </p:spPr>
-        <p:txBody>
-          <a:bodyPr wrap="square" lIns="0" tIns="0" rIns="0" bIns="0" rtlCol="0" anchor="t"/>
-          <a:lstStyle/>
-          <a:p>
-            <a:pPr marL="0" indent="0">
-              <a:buNone/>
-            </a:pPr>
-            <a:r>
-              <a:rPr lang="en-US" sz="1800" b="1" dirty="0">
-                <a:solidFill>
-                  <a:srgbClr val="397C25"/>
-                </a:solidFill>
-                <a:latin typeface="Calibri" pitchFamily="34" charset="0"/>
-                <a:ea typeface="Calibri" pitchFamily="34" charset="-122"/>
-                <a:cs typeface="Calibri" pitchFamily="34" charset="-120"/>
-              </a:rPr>
-              <a:t>Observe recall in the memory-aware flow; exact model wording can vary.</a:t>
-            </a:r>
-            <a:endParaRPr lang="en-US" sz="1800" dirty="0"/>
-          </a:p>
-        </p:txBody>
-      </p:sp>
     </p:spTree>
   </p:cSld>
   <p:clrMapOvr>
@@ -10278,8 +9927,8 @@
         </p:nvSpPr>
         <p:spPr>
           <a:xfrm>
-            <a:off x="548640" y="950976"/>
-            <a:ext cx="10972800" cy="1197864"/>
+            <a:off x="645232" y="2888731"/>
+            <a:ext cx="1615011" cy="678201"/>
           </a:xfrm>
           <a:prstGeom prst="rect">
             <a:avLst/>
@@ -10303,7 +9952,7 @@
                 <a:ea typeface="Trebuchet MS" pitchFamily="34" charset="-122"/>
                 <a:cs typeface="Trebuchet MS" pitchFamily="34" charset="-120"/>
               </a:rPr>
-              <a:t>Make the memory boundary visible</a:t>
+              <a:t>Demo</a:t>
             </a:r>
             <a:endParaRPr lang="en-US" sz="4000" dirty="0"/>
           </a:p>
@@ -10311,124 +9960,91 @@
       </p:sp>
       <p:sp>
         <p:nvSpPr>
-          <p:cNvPr id="4" name="Text 2"/>
-          <p:cNvSpPr/>
-          <p:nvPr/>
-        </p:nvSpPr>
-        <p:spPr>
-          <a:xfrm>
-            <a:off x="548640" y="2423160"/>
-            <a:ext cx="4572000" cy="850392"/>
-          </a:xfrm>
-          <a:prstGeom prst="rect">
-            <a:avLst/>
-          </a:prstGeom>
-          <a:noFill/>
-          <a:ln/>
-        </p:spPr>
-        <p:txBody>
-          <a:bodyPr wrap="square" lIns="0" tIns="0" rIns="0" bIns="0" rtlCol="0" anchor="t"/>
-          <a:lstStyle/>
-          <a:p>
-            <a:pPr marL="0" indent="0">
-              <a:buNone/>
-            </a:pPr>
-            <a:r>
-              <a:rPr lang="en-US" sz="2100" dirty="0">
-                <a:solidFill>
-                  <a:srgbClr val="FFFFFF"/>
-                </a:solidFill>
-                <a:latin typeface="Calibri" pitchFamily="34" charset="0"/>
-                <a:ea typeface="Calibri" pitchFamily="34" charset="-122"/>
-                <a:cs typeface="Calibri" pitchFamily="34" charset="-120"/>
-              </a:rPr>
-              <a:t>Set maxMessages to 4; rebuild and restart.</a:t>
-            </a:r>
-            <a:endParaRPr lang="en-US" sz="2100" dirty="0"/>
-          </a:p>
-        </p:txBody>
-      </p:sp>
-      <p:sp>
-        <p:nvSpPr>
-          <p:cNvPr id="5" name="Text 3"/>
-          <p:cNvSpPr/>
-          <p:nvPr/>
-        </p:nvSpPr>
-        <p:spPr>
-          <a:xfrm>
-            <a:off x="548640" y="3410712"/>
-            <a:ext cx="4572000" cy="850392"/>
-          </a:xfrm>
-          <a:prstGeom prst="rect">
-            <a:avLst/>
-          </a:prstGeom>
-          <a:noFill/>
-          <a:ln/>
-        </p:spPr>
-        <p:txBody>
-          <a:bodyPr wrap="square" lIns="0" tIns="0" rIns="0" bIns="0" rtlCol="0" anchor="t"/>
-          <a:lstStyle/>
-          <a:p>
-            <a:pPr marL="0" indent="0">
-              <a:buNone/>
-            </a:pPr>
-            <a:r>
-              <a:rPr lang="en-US" sz="2100" dirty="0">
-                <a:solidFill>
-                  <a:srgbClr val="FFFFFF"/>
-                </a:solidFill>
-                <a:latin typeface="Calibri" pitchFamily="34" charset="0"/>
-                <a:ea typeface="Calibri" pitchFamily="34" charset="-122"/>
-                <a:cs typeface="Calibri" pitchFamily="34" charset="-120"/>
-              </a:rPr>
-              <a:t>Compare retained history across several turns and two IDs.</a:t>
-            </a:r>
-            <a:endParaRPr lang="en-US" sz="2100" dirty="0"/>
-          </a:p>
-        </p:txBody>
-      </p:sp>
-      <p:sp>
-        <p:nvSpPr>
-          <p:cNvPr id="6" name="Text 4"/>
-          <p:cNvSpPr/>
-          <p:nvPr/>
-        </p:nvSpPr>
-        <p:spPr>
-          <a:xfrm>
-            <a:off x="548640" y="4398264"/>
-            <a:ext cx="4572000" cy="850392"/>
-          </a:xfrm>
-          <a:prstGeom prst="rect">
-            <a:avLst/>
-          </a:prstGeom>
-          <a:noFill/>
-          <a:ln/>
-        </p:spPr>
-        <p:txBody>
-          <a:bodyPr wrap="square" lIns="0" tIns="0" rIns="0" bIns="0" rtlCol="0" anchor="t"/>
-          <a:lstStyle/>
-          <a:p>
-            <a:pPr marL="0" indent="0">
-              <a:buNone/>
-            </a:pPr>
-            <a:r>
-              <a:rPr lang="en-US" sz="2100" dirty="0">
-                <a:solidFill>
-                  <a:srgbClr val="FFFFFF"/>
-                </a:solidFill>
-                <a:latin typeface="Calibri" pitchFamily="34" charset="0"/>
-                <a:ea typeface="Calibri" pitchFamily="34" charset="-122"/>
-                <a:cs typeface="Calibri" pitchFamily="34" charset="-120"/>
-              </a:rPr>
-              <a:t>Restart again to verify that in-memory history is temporary.</a:t>
-            </a:r>
-            <a:endParaRPr lang="en-US" sz="2100" dirty="0"/>
+          <p:cNvPr id="9" name="Text 6"/>
+          <p:cNvSpPr/>
+          <p:nvPr/>
+        </p:nvSpPr>
+        <p:spPr>
+          <a:xfrm>
+            <a:off x="548640" y="6400800"/>
+            <a:ext cx="9875520" cy="210312"/>
+          </a:xfrm>
+          <a:prstGeom prst="rect">
+            <a:avLst/>
+          </a:prstGeom>
+          <a:noFill/>
+          <a:ln/>
+        </p:spPr>
+        <p:txBody>
+          <a:bodyPr wrap="square" lIns="0" tIns="0" rIns="0" bIns="0" rtlCol="0" anchor="t"/>
+          <a:lstStyle/>
+          <a:p>
+            <a:pPr marL="0" indent="0">
+              <a:buNone/>
+            </a:pPr>
+            <a:r>
+              <a:rPr lang="en-US" sz="1050" dirty="0">
+                <a:solidFill>
+                  <a:srgbClr val="B9CBB9"/>
+                </a:solidFill>
+                <a:latin typeface="Calibri" pitchFamily="34" charset="0"/>
+                <a:ea typeface="Calibri" pitchFamily="34" charset="-122"/>
+                <a:cs typeface="Calibri" pitchFamily="34" charset="-120"/>
+              </a:rPr>
+              <a:t>SPRING AI FOR BEGINNERS  /  01 Getting Started</a:t>
+            </a:r>
+            <a:endParaRPr lang="en-US" sz="1050" dirty="0"/>
+          </a:p>
+        </p:txBody>
+      </p:sp>
+      <p:sp>
+        <p:nvSpPr>
+          <p:cNvPr id="10" name="Text 7"/>
+          <p:cNvSpPr/>
+          <p:nvPr/>
+        </p:nvSpPr>
+        <p:spPr>
+          <a:xfrm>
+            <a:off x="10817352" y="6373368"/>
+            <a:ext cx="822960" cy="256032"/>
+          </a:xfrm>
+          <a:prstGeom prst="rect">
+            <a:avLst/>
+          </a:prstGeom>
+          <a:noFill/>
+          <a:ln/>
+        </p:spPr>
+        <p:txBody>
+          <a:bodyPr wrap="square" lIns="0" tIns="0" rIns="0" bIns="0" rtlCol="0" anchor="t"/>
+          <a:lstStyle/>
+          <a:p>
+            <a:pPr marL="0" indent="0" algn="r">
+              <a:buNone/>
+            </a:pPr>
+            <a:r>
+              <a:rPr lang="en-US" sz="1200" dirty="0">
+                <a:solidFill>
+                  <a:srgbClr val="B9CBB9"/>
+                </a:solidFill>
+                <a:latin typeface="Calibri" pitchFamily="34" charset="0"/>
+                <a:ea typeface="Calibri" pitchFamily="34" charset="-122"/>
+                <a:cs typeface="Calibri" pitchFamily="34" charset="-120"/>
+              </a:rPr>
+              <a:t>19 / 19</a:t>
+            </a:r>
+            <a:endParaRPr lang="en-US" sz="1200" dirty="0"/>
           </a:p>
         </p:txBody>
       </p:sp>
       <p:pic>
         <p:nvPicPr>
-          <p:cNvPr id="7" name="Image 0" descr="home screen"/>
+          <p:cNvPr id="13" name="Picture 12" descr="QR Code">
+            <a:extLst>
+              <a:ext uri="{FF2B5EF4-FFF2-40B4-BE49-F238E27FC236}">
+                <a16:creationId xmlns:a16="http://schemas.microsoft.com/office/drawing/2014/main" id="{B1D7F7F2-EDE2-8964-E129-78C85C40ADFD}"/>
+              </a:ext>
+            </a:extLst>
+          </p:cNvPr>
           <p:cNvPicPr>
             <a:picLocks noChangeAspect="1"/>
           </p:cNvPicPr>
@@ -10442,8 +10058,8 @@
         </p:blipFill>
         <p:spPr>
           <a:xfrm>
-            <a:off x="5486400" y="3090802"/>
-            <a:ext cx="6153912" cy="1737100"/>
+            <a:off x="3574694" y="675763"/>
+            <a:ext cx="5143500" cy="5143500"/>
           </a:xfrm>
           <a:prstGeom prst="rect">
             <a:avLst/>
@@ -10452,118 +10068,40 @@
       </p:pic>
       <p:sp>
         <p:nvSpPr>
-          <p:cNvPr id="8" name="Text 5"/>
-          <p:cNvSpPr/>
-          <p:nvPr/>
-        </p:nvSpPr>
-        <p:spPr>
-          <a:xfrm>
-            <a:off x="548640" y="5815584"/>
-            <a:ext cx="11064240" cy="448056"/>
-          </a:xfrm>
-          <a:prstGeom prst="rect">
-            <a:avLst/>
-          </a:prstGeom>
-          <a:noFill/>
-          <a:ln/>
-        </p:spPr>
-        <p:txBody>
-          <a:bodyPr wrap="square" lIns="0" tIns="0" rIns="0" bIns="0" rtlCol="0" anchor="t"/>
-          <a:lstStyle/>
-          <a:p>
-            <a:pPr marL="0" indent="0">
-              <a:buNone/>
-            </a:pPr>
-            <a:r>
-              <a:rPr lang="en-US" sz="1800" b="1" dirty="0">
-                <a:solidFill>
-                  <a:srgbClr val="86CF54"/>
-                </a:solidFill>
-                <a:latin typeface="Calibri" pitchFamily="34" charset="0"/>
-                <a:ea typeface="Calibri" pitchFamily="34" charset="-122"/>
-                <a:cs typeface="Calibri" pitchFamily="34" charset="-120"/>
-              </a:rPr>
-              <a:t>Next: shape the request itself with Spring AI prompt engineering.</a:t>
-            </a:r>
-            <a:endParaRPr lang="en-US" sz="1800" dirty="0"/>
-          </a:p>
-        </p:txBody>
-      </p:sp>
-      <p:sp>
-        <p:nvSpPr>
-          <p:cNvPr id="9" name="Text 6"/>
-          <p:cNvSpPr/>
-          <p:nvPr/>
-        </p:nvSpPr>
-        <p:spPr>
-          <a:xfrm>
-            <a:off x="548640" y="6400800"/>
-            <a:ext cx="9875520" cy="210312"/>
-          </a:xfrm>
-          <a:prstGeom prst="rect">
-            <a:avLst/>
-          </a:prstGeom>
-          <a:noFill/>
-          <a:ln/>
-        </p:spPr>
-        <p:txBody>
-          <a:bodyPr wrap="square" lIns="0" tIns="0" rIns="0" bIns="0" rtlCol="0" anchor="t"/>
-          <a:lstStyle/>
-          <a:p>
-            <a:pPr marL="0" indent="0">
-              <a:buNone/>
-            </a:pPr>
-            <a:r>
-              <a:rPr lang="en-US" sz="1050" dirty="0">
-                <a:solidFill>
-                  <a:srgbClr val="B9CBB9"/>
-                </a:solidFill>
-                <a:latin typeface="Calibri" pitchFamily="34" charset="0"/>
-                <a:ea typeface="Calibri" pitchFamily="34" charset="-122"/>
-                <a:cs typeface="Calibri" pitchFamily="34" charset="-120"/>
-              </a:rPr>
-              <a:t>SPRING AI FOR BEGINNERS  /  01 Getting Started</a:t>
-            </a:r>
-            <a:endParaRPr lang="en-US" sz="1050" dirty="0"/>
-          </a:p>
-        </p:txBody>
-      </p:sp>
-      <p:sp>
-        <p:nvSpPr>
-          <p:cNvPr id="10" name="Text 7"/>
-          <p:cNvSpPr/>
-          <p:nvPr/>
-        </p:nvSpPr>
-        <p:spPr>
-          <a:xfrm>
-            <a:off x="10817352" y="6373368"/>
-            <a:ext cx="822960" cy="256032"/>
-          </a:xfrm>
-          <a:prstGeom prst="rect">
-            <a:avLst/>
-          </a:prstGeom>
-          <a:noFill/>
-          <a:ln/>
-        </p:spPr>
-        <p:txBody>
-          <a:bodyPr wrap="square" lIns="0" tIns="0" rIns="0" bIns="0" rtlCol="0" anchor="t"/>
-          <a:lstStyle/>
-          <a:p>
-            <a:pPr marL="0" indent="0" algn="r">
-              <a:buNone/>
-            </a:pPr>
-            <a:r>
-              <a:rPr lang="en-US" sz="1200" dirty="0">
-                <a:solidFill>
-                  <a:srgbClr val="B9CBB9"/>
-                </a:solidFill>
-                <a:latin typeface="Calibri" pitchFamily="34" charset="0"/>
-                <a:ea typeface="Calibri" pitchFamily="34" charset="-122"/>
-                <a:cs typeface="Calibri" pitchFamily="34" charset="-120"/>
-              </a:rPr>
-              <a:t>19 / 19</a:t>
-            </a:r>
-            <a:endParaRPr lang="en-US" sz="1200" dirty="0"/>
+          <p:cNvPr id="15" name="TextBox 14">
+            <a:extLst>
+              <a:ext uri="{FF2B5EF4-FFF2-40B4-BE49-F238E27FC236}">
+                <a16:creationId xmlns:a16="http://schemas.microsoft.com/office/drawing/2014/main" id="{255AC8FB-F109-D683-AD44-28805CFC161A}"/>
+              </a:ext>
+            </a:extLst>
+          </p:cNvPr>
+          <p:cNvSpPr txBox="1"/>
+          <p:nvPr/>
+        </p:nvSpPr>
+        <p:spPr>
+          <a:xfrm>
+            <a:off x="2869576" y="5816025"/>
+            <a:ext cx="6553736" cy="584775"/>
+          </a:xfrm>
+          <a:prstGeom prst="rect">
+            <a:avLst/>
+          </a:prstGeom>
+          <a:noFill/>
+        </p:spPr>
+        <p:txBody>
+          <a:bodyPr wrap="square">
+            <a:spAutoFit/>
+          </a:bodyPr>
+          <a:lstStyle/>
+          <a:p>
+            <a:r>
+              <a:rPr lang="en-ZA" sz="3200" dirty="0">
+                <a:solidFill>
+                  <a:schemeClr val="bg2"/>
+                </a:solidFill>
+              </a:rPr>
+              <a:t>http://aka.ms/Spring-AI-for-Beginners</a:t>
+            </a:r>
           </a:p>
         </p:txBody>
       </p:sp>
@@ -11740,45 +11278,6 @@
           </a:p>
         </p:txBody>
       </p:sp>
-      <p:sp>
-        <p:nvSpPr>
-          <p:cNvPr id="34" name="Text 30"/>
-          <p:cNvSpPr/>
-          <p:nvPr/>
-        </p:nvSpPr>
-        <p:spPr>
-          <a:xfrm>
-            <a:off x="548640" y="5815584"/>
-            <a:ext cx="11064240" cy="448056"/>
-          </a:xfrm>
-          <a:prstGeom prst="rect">
-            <a:avLst/>
-          </a:prstGeom>
-          <a:noFill/>
-          <a:ln/>
-        </p:spPr>
-        <p:txBody>
-          <a:bodyPr wrap="square" lIns="0" tIns="0" rIns="0" bIns="0" rtlCol="0" anchor="t"/>
-          <a:lstStyle/>
-          <a:p>
-            <a:pPr marL="0" indent="0">
-              <a:buNone/>
-            </a:pPr>
-            <a:r>
-              <a:rPr lang="en-US" sz="1800" b="1" dirty="0">
-                <a:solidFill>
-                  <a:srgbClr val="397C25"/>
-                </a:solidFill>
-                <a:latin typeface="Calibri" pitchFamily="34" charset="0"/>
-                <a:ea typeface="Calibri" pitchFamily="34" charset="-122"/>
-                <a:cs typeface="Calibri" pitchFamily="34" charset="-120"/>
-              </a:rPr>
-              <a:t>LLM = large language model. An advisor augments the request and handles the response around the call.</a:t>
-            </a:r>
-            <a:endParaRPr lang="en-US" sz="1800" dirty="0"/>
-          </a:p>
-        </p:txBody>
-      </p:sp>
     </p:spTree>
   </p:cSld>
   <p:clrMapOvr>
@@ -12279,45 +11778,6 @@
           </a:p>
         </p:txBody>
       </p:sp>
-      <p:sp>
-        <p:nvSpPr>
-          <p:cNvPr id="15" name="Text 11"/>
-          <p:cNvSpPr/>
-          <p:nvPr/>
-        </p:nvSpPr>
-        <p:spPr>
-          <a:xfrm>
-            <a:off x="548640" y="5815584"/>
-            <a:ext cx="11064240" cy="448056"/>
-          </a:xfrm>
-          <a:prstGeom prst="rect">
-            <a:avLst/>
-          </a:prstGeom>
-          <a:noFill/>
-          <a:ln/>
-        </p:spPr>
-        <p:txBody>
-          <a:bodyPr wrap="square" lIns="0" tIns="0" rIns="0" bIns="0" rtlCol="0" anchor="t"/>
-          <a:lstStyle/>
-          <a:p>
-            <a:pPr marL="0" indent="0">
-              <a:buNone/>
-            </a:pPr>
-            <a:r>
-              <a:rPr lang="en-US" sz="1800" b="1" dirty="0">
-                <a:solidFill>
-                  <a:srgbClr val="397C25"/>
-                </a:solidFill>
-                <a:latin typeface="Calibri" pitchFamily="34" charset="0"/>
-                <a:ea typeface="Calibri" pitchFamily="34" charset="-122"/>
-                <a:cs typeface="Calibri" pitchFamily="34" charset="-120"/>
-              </a:rPr>
-              <a:t>Both panels use the same configured deployment: gpt-5.6-luna.</a:t>
-            </a:r>
-            <a:endParaRPr lang="en-US" sz="1800" dirty="0"/>
-          </a:p>
-        </p:txBody>
-      </p:sp>
     </p:spTree>
   </p:cSld>
   <p:clrMapOvr>
@@ -13111,45 +12571,6 @@
           </a:p>
         </p:txBody>
       </p:sp>
-      <p:sp>
-        <p:nvSpPr>
-          <p:cNvPr id="22" name="Text 20"/>
-          <p:cNvSpPr/>
-          <p:nvPr/>
-        </p:nvSpPr>
-        <p:spPr>
-          <a:xfrm>
-            <a:off x="548640" y="5815584"/>
-            <a:ext cx="11064240" cy="448056"/>
-          </a:xfrm>
-          <a:prstGeom prst="rect">
-            <a:avLst/>
-          </a:prstGeom>
-          <a:noFill/>
-          <a:ln/>
-        </p:spPr>
-        <p:txBody>
-          <a:bodyPr wrap="square" lIns="0" tIns="0" rIns="0" bIns="0" rtlCol="0" anchor="t"/>
-          <a:lstStyle/>
-          <a:p>
-            <a:pPr marL="0" indent="0">
-              <a:buNone/>
-            </a:pPr>
-            <a:r>
-              <a:rPr lang="en-US" sz="1800" b="1" dirty="0">
-                <a:solidFill>
-                  <a:srgbClr val="397C25"/>
-                </a:solidFill>
-                <a:latin typeface="Calibri" pitchFamily="34" charset="0"/>
-                <a:ea typeface="Calibri" pitchFamily="34" charset="-122"/>
-                <a:cs typeface="Calibri" pitchFamily="34" charset="-120"/>
-              </a:rPr>
-              <a:t>Spring Boot wires the infrastructure; your service expresses the AI workflow.</a:t>
-            </a:r>
-            <a:endParaRPr lang="en-US" sz="1800" dirty="0"/>
-          </a:p>
-        </p:txBody>
-      </p:sp>
     </p:spTree>
   </p:cSld>
   <p:clrMapOvr>
@@ -13826,45 +13247,6 @@
           </a:p>
         </p:txBody>
       </p:sp>
-      <p:sp>
-        <p:nvSpPr>
-          <p:cNvPr id="15" name="Text 13"/>
-          <p:cNvSpPr/>
-          <p:nvPr/>
-        </p:nvSpPr>
-        <p:spPr>
-          <a:xfrm>
-            <a:off x="548640" y="5815584"/>
-            <a:ext cx="11064240" cy="448056"/>
-          </a:xfrm>
-          <a:prstGeom prst="rect">
-            <a:avLst/>
-          </a:prstGeom>
-          <a:noFill/>
-          <a:ln/>
-        </p:spPr>
-        <p:txBody>
-          <a:bodyPr wrap="square" lIns="0" tIns="0" rIns="0" bIns="0" rtlCol="0" anchor="t"/>
-          <a:lstStyle/>
-          <a:p>
-            <a:pPr marL="0" indent="0">
-              <a:buNone/>
-            </a:pPr>
-            <a:r>
-              <a:rPr lang="en-US" sz="1800" b="1" dirty="0">
-                <a:solidFill>
-                  <a:srgbClr val="397C25"/>
-                </a:solidFill>
-                <a:latin typeface="Calibri" pitchFamily="34" charset="0"/>
-                <a:ea typeface="Calibri" pitchFamily="34" charset="-122"/>
-                <a:cs typeface="Calibri" pitchFamily="34" charset="-120"/>
-              </a:rPr>
-              <a:t>Provider SDK integration + Boot auto-configuration = the model starter.</a:t>
-            </a:r>
-            <a:endParaRPr lang="en-US" sz="1800" dirty="0"/>
-          </a:p>
-        </p:txBody>
-      </p:sp>
     </p:spTree>
   </p:cSld>
   <p:clrMapOvr>
@@ -14563,45 +13945,6 @@
           </a:p>
         </p:txBody>
       </p:sp>
-      <p:sp>
-        <p:nvSpPr>
-          <p:cNvPr id="15" name="Text 13"/>
-          <p:cNvSpPr/>
-          <p:nvPr/>
-        </p:nvSpPr>
-        <p:spPr>
-          <a:xfrm>
-            <a:off x="548640" y="5815584"/>
-            <a:ext cx="11064240" cy="448056"/>
-          </a:xfrm>
-          <a:prstGeom prst="rect">
-            <a:avLst/>
-          </a:prstGeom>
-          <a:noFill/>
-          <a:ln/>
-        </p:spPr>
-        <p:txBody>
-          <a:bodyPr wrap="square" lIns="0" tIns="0" rIns="0" bIns="0" rtlCol="0" anchor="t"/>
-          <a:lstStyle/>
-          <a:p>
-            <a:pPr marL="0" indent="0">
-              <a:buNone/>
-            </a:pPr>
-            <a:r>
-              <a:rPr lang="en-US" sz="1800" b="1" dirty="0">
-                <a:solidFill>
-                  <a:srgbClr val="397C25"/>
-                </a:solidFill>
-                <a:latin typeface="Calibri" pitchFamily="34" charset="0"/>
-                <a:ea typeface="Calibri" pitchFamily="34" charset="-122"/>
-                <a:cs typeface="Calibri" pitchFamily="34" charset="-120"/>
-              </a:rPr>
-              <a:t>Keep credentials out of source code, slides, and projected terminal output.</a:t>
-            </a:r>
-            <a:endParaRPr lang="en-US" sz="1800" dirty="0"/>
-          </a:p>
-        </p:txBody>
-      </p:sp>
     </p:spTree>
   </p:cSld>
   <p:clrMapOvr>
@@ -15229,45 +14572,6 @@
           </a:p>
         </p:txBody>
       </p:sp>
-      <p:sp>
-        <p:nvSpPr>
-          <p:cNvPr id="15" name="Text 13"/>
-          <p:cNvSpPr/>
-          <p:nvPr/>
-        </p:nvSpPr>
-        <p:spPr>
-          <a:xfrm>
-            <a:off x="548640" y="5815584"/>
-            <a:ext cx="11064240" cy="448056"/>
-          </a:xfrm>
-          <a:prstGeom prst="rect">
-            <a:avLst/>
-          </a:prstGeom>
-          <a:noFill/>
-          <a:ln/>
-        </p:spPr>
-        <p:txBody>
-          <a:bodyPr wrap="square" lIns="0" tIns="0" rIns="0" bIns="0" rtlCol="0" anchor="t"/>
-          <a:lstStyle/>
-          <a:p>
-            <a:pPr marL="0" indent="0">
-              <a:buNone/>
-            </a:pPr>
-            <a:r>
-              <a:rPr lang="en-US" sz="1800" b="1" dirty="0">
-                <a:solidFill>
-                  <a:srgbClr val="397C25"/>
-                </a:solidFill>
-                <a:latin typeface="Calibri" pitchFamily="34" charset="0"/>
-                <a:ea typeface="Calibri" pitchFamily="34" charset="-122"/>
-                <a:cs typeface="Calibri" pitchFamily="34" charset="-120"/>
-              </a:rPr>
-              <a:t>No memory advisor means no automatic replay of previous turns.</a:t>
-            </a:r>
-            <a:endParaRPr lang="en-US" sz="1800" dirty="0"/>
-          </a:p>
-        </p:txBody>
-      </p:sp>
     </p:spTree>
   </p:cSld>
   <p:clrMapOvr>
@@ -15715,45 +15019,6 @@
           </a:p>
         </p:txBody>
       </p:sp>
-      <p:sp>
-        <p:nvSpPr>
-          <p:cNvPr id="13" name="Text 10"/>
-          <p:cNvSpPr/>
-          <p:nvPr/>
-        </p:nvSpPr>
-        <p:spPr>
-          <a:xfrm>
-            <a:off x="548640" y="5815584"/>
-            <a:ext cx="11064240" cy="448056"/>
-          </a:xfrm>
-          <a:prstGeom prst="rect">
-            <a:avLst/>
-          </a:prstGeom>
-          <a:noFill/>
-          <a:ln/>
-        </p:spPr>
-        <p:txBody>
-          <a:bodyPr wrap="square" lIns="0" tIns="0" rIns="0" bIns="0" rtlCol="0" anchor="t"/>
-          <a:lstStyle/>
-          <a:p>
-            <a:pPr marL="0" indent="0">
-              <a:buNone/>
-            </a:pPr>
-            <a:r>
-              <a:rPr lang="en-US" sz="1800" b="1" dirty="0">
-                <a:solidFill>
-                  <a:srgbClr val="397C25"/>
-                </a:solidFill>
-                <a:latin typeface="Calibri" pitchFamily="34" charset="0"/>
-                <a:ea typeface="Calibri" pitchFamily="34" charset="-122"/>
-                <a:cs typeface="Calibri" pitchFamily="34" charset="-120"/>
-              </a:rPr>
-              <a:t>Tokens are text pieces, not always whole words. The pictured count is illustrative and model-dependent.</a:t>
-            </a:r>
-            <a:endParaRPr lang="en-US" sz="1800" dirty="0"/>
-          </a:p>
-        </p:txBody>
-      </p:sp>
     </p:spTree>
   </p:cSld>
   <p:clrMapOvr>
@@ -16544,45 +15809,6 @@
               <a:t>The after() hook saves the returned assistant messages.</a:t>
             </a:r>
             <a:endParaRPr lang="en-US" sz="2200" dirty="0"/>
-          </a:p>
-        </p:txBody>
-      </p:sp>
-      <p:sp>
-        <p:nvSpPr>
-          <p:cNvPr id="22" name="Text 20"/>
-          <p:cNvSpPr/>
-          <p:nvPr/>
-        </p:nvSpPr>
-        <p:spPr>
-          <a:xfrm>
-            <a:off x="548640" y="5815584"/>
-            <a:ext cx="11064240" cy="448056"/>
-          </a:xfrm>
-          <a:prstGeom prst="rect">
-            <a:avLst/>
-          </a:prstGeom>
-          <a:noFill/>
-          <a:ln/>
-        </p:spPr>
-        <p:txBody>
-          <a:bodyPr wrap="square" lIns="0" tIns="0" rIns="0" bIns="0" rtlCol="0" anchor="t"/>
-          <a:lstStyle/>
-          <a:p>
-            <a:pPr marL="0" indent="0">
-              <a:buNone/>
-            </a:pPr>
-            <a:r>
-              <a:rPr lang="en-US" sz="1800" b="1" dirty="0">
-                <a:solidFill>
-                  <a:srgbClr val="397C25"/>
-                </a:solidFill>
-                <a:latin typeface="Calibri" pitchFamily="34" charset="0"/>
-                <a:ea typeface="Calibri" pitchFamily="34" charset="-122"/>
-                <a:cs typeface="Calibri" pitchFamily="34" charset="-120"/>
-              </a:rPr>
-              <a:t>The user message is stored before the model call; a failed call can leave an unanswered user turn.</a:t>
-            </a:r>
-            <a:endParaRPr lang="en-US" sz="1800" dirty="0"/>
           </a:p>
         </p:txBody>
       </p:sp>

</xml_diff>